<commit_message>
Fix roadmap slide 2 status colors, tidy README title, refresh notebook outputs
</commit_message>
<xml_diff>
--- a/roadmap.pptx
+++ b/roadmap.pptx
@@ -4109,7 +4109,7 @@
         <p:spPr>
           <a:xfrm>
             <a:off x="457200" y="3246120"/>
-            <a:ext cx="1056640" cy="201168"/>
+            <a:ext cx="2377440" cy="201168"/>
           </a:xfrm>
           <a:prstGeom prst="roundRect">
             <a:avLst>
@@ -4117,7 +4117,7 @@
             </a:avLst>
           </a:prstGeom>
           <a:solidFill>
-            <a:srgbClr val="C9791A"/>
+            <a:srgbClr val="0B6E4F"/>
           </a:solidFill>
           <a:ln/>
         </p:spPr>
@@ -4769,7 +4769,7 @@
             <a:avLst/>
           </a:prstGeom>
           <a:solidFill>
-            <a:srgbClr val="C98F12"/>
+            <a:srgbClr val="0B6E4F"/>
           </a:solidFill>
           <a:ln/>
         </p:spPr>
@@ -5375,7 +5375,7 @@
             </a:avLst>
           </a:prstGeom>
           <a:solidFill>
-            <a:srgbClr val="FCEDC7"/>
+            <a:srgbClr val="E4F2EC"/>
           </a:solidFill>
           <a:ln/>
           <a:effectLst>
@@ -5409,7 +5409,7 @@
             <a:avLst/>
           </a:prstGeom>
           <a:solidFill>
-            <a:srgbClr val="C98F12"/>
+            <a:srgbClr val="0B6E4F"/>
           </a:solidFill>
           <a:ln/>
         </p:spPr>
@@ -5655,9 +5655,6 @@
             <a:pPr algn="ctr"/>
             <a:r>
               <a:rPr lang="en-US" sz="900" b="1">
-                <a:solidFill>
-                  <a:srgbClr val="C98F12"/>
-                </a:solidFill>
                 <a:ea typeface="Calibri"/>
                 <a:cs typeface="Calibri"/>
               </a:rPr>
@@ -5690,7 +5687,7 @@
             </a:avLst>
           </a:prstGeom>
           <a:solidFill>
-            <a:srgbClr val="FBE1CC"/>
+            <a:srgbClr val="E4F2EC"/>
           </a:solidFill>
           <a:ln/>
           <a:effectLst>
@@ -5724,7 +5721,7 @@
             <a:avLst/>
           </a:prstGeom>
           <a:solidFill>
-            <a:srgbClr val="BF5B23"/>
+            <a:srgbClr val="0B6E4F"/>
           </a:solidFill>
           <a:ln/>
         </p:spPr>
@@ -5975,9 +5972,6 @@
             </a:pPr>
             <a:r>
               <a:rPr lang="en-US" sz="900" b="1" dirty="0">
-                <a:solidFill>
-                  <a:srgbClr val="000000"/>
-                </a:solidFill>
                 <a:latin typeface="Calibri" pitchFamily="34" charset="0"/>
                 <a:ea typeface="Calibri" pitchFamily="34" charset="-122"/>
                 <a:cs typeface="Calibri" pitchFamily="34" charset="-120"/>
@@ -6005,7 +5999,7 @@
             </a:avLst>
           </a:prstGeom>
           <a:solidFill>
-            <a:srgbClr val="F1F2F3"/>
+            <a:srgbClr val="E4F2EC"/>
           </a:solidFill>
           <a:ln/>
           <a:effectLst>
@@ -6039,7 +6033,7 @@
             <a:avLst/>
           </a:prstGeom>
           <a:solidFill>
-            <a:srgbClr val="9AA0A6"/>
+            <a:srgbClr val="0B6E4F"/>
           </a:solidFill>
           <a:ln/>
         </p:spPr>
@@ -6287,9 +6281,6 @@
             </a:pPr>
             <a:r>
               <a:rPr lang="en-US" sz="900" b="1" dirty="0">
-                <a:solidFill>
-                  <a:srgbClr val="8A9096"/>
-                </a:solidFill>
                 <a:latin typeface="Calibri" pitchFamily="34" charset="0"/>
                 <a:ea typeface="Calibri" pitchFamily="34" charset="-122"/>
                 <a:cs typeface="Calibri" pitchFamily="34" charset="-120"/>
@@ -6317,7 +6308,7 @@
             </a:avLst>
           </a:prstGeom>
           <a:solidFill>
-            <a:srgbClr val="F1F2F3"/>
+            <a:srgbClr val="E4F2EC"/>
           </a:solidFill>
           <a:ln/>
           <a:effectLst>
@@ -6351,7 +6342,7 @@
             <a:avLst/>
           </a:prstGeom>
           <a:solidFill>
-            <a:srgbClr val="9AA0A6"/>
+            <a:srgbClr val="0B6E4F"/>
           </a:solidFill>
           <a:ln/>
         </p:spPr>
@@ -6599,9 +6590,6 @@
             </a:pPr>
             <a:r>
               <a:rPr lang="en-US" sz="900" b="1" dirty="0">
-                <a:solidFill>
-                  <a:srgbClr val="8A9096"/>
-                </a:solidFill>
                 <a:latin typeface="Calibri" pitchFamily="34" charset="0"/>
                 <a:ea typeface="Calibri" pitchFamily="34" charset="-122"/>
                 <a:cs typeface="Calibri" pitchFamily="34" charset="-120"/>
@@ -6934,7 +6922,7 @@
             </a:avLst>
           </a:prstGeom>
           <a:solidFill>
-            <a:srgbClr val="F1F2F3"/>
+            <a:srgbClr val="E4F2EC"/>
           </a:solidFill>
           <a:ln/>
           <a:effectLst>
@@ -6968,7 +6956,7 @@
             <a:avLst/>
           </a:prstGeom>
           <a:solidFill>
-            <a:srgbClr val="9AA0A6"/>
+            <a:srgbClr val="0B6E4F"/>
           </a:solidFill>
           <a:ln/>
         </p:spPr>
@@ -7216,9 +7204,6 @@
             </a:pPr>
             <a:r>
               <a:rPr lang="en-US" sz="900" b="1" dirty="0">
-                <a:solidFill>
-                  <a:srgbClr val="8A9096"/>
-                </a:solidFill>
                 <a:latin typeface="Calibri" pitchFamily="34" charset="0"/>
                 <a:ea typeface="Calibri" pitchFamily="34" charset="-122"/>
                 <a:cs typeface="Calibri" pitchFamily="34" charset="-120"/>

</xml_diff>

<commit_message>
Add roadmap slide 5: minimum requirements complete, and what comes next
Appends a status slide (the four original slides are untouched, per the
established convention). Green banner for the 7/7 core requirements and 9/9
roadmap items, then three cards for what follows: alphanumeric fault codes
(marked IN PROGRESS, the active work), extensive real-world testing (NEXT),
and audio diagnostics (EXPLORING, an extra beyond the core requirements).

Co-Authored-By: Claude Sonnet 5 <noreply@anthropic.com>
Claude-Session: https://claude.ai/code/session_011iVgkFb4vk7QSuG3Z7ovqV
</commit_message>
<xml_diff>
--- a/roadmap.pptx
+++ b/roadmap.pptx
@@ -12,6 +12,7 @@
     <p:sldId id="259" r:id="rId3"/>
     <p:sldId id="260" r:id="rId4"/>
     <p:sldId id="261" r:id="rId5"/>
+    <p:sldId id="262" r:id="rId13"/>
   </p:sldIdLst>
   <p:sldSz cx="12192000" cy="6858000"/>
   <p:notesSz cx="6858000" cy="12192000"/>
@@ -8083,6 +8084,1167 @@
 </p:sld>
 </file>
 
+<file path=ppt/slides/slide5.xml><?xml version="1.0" encoding="utf-8"?>
+<p:sld xmlns:a="http://schemas.openxmlformats.org/drawingml/2006/main" xmlns:p="http://schemas.openxmlformats.org/presentationml/2006/main" xmlns:r="http://schemas.openxmlformats.org/officeDocument/2006/relationships">
+  <p:cSld>
+    <p:spTree>
+      <p:nvGrpSpPr>
+        <p:cNvPr id="1" name=""/>
+        <p:cNvGrpSpPr/>
+        <p:nvPr/>
+      </p:nvGrpSpPr>
+      <p:grpSpPr/>
+      <p:sp>
+        <p:nvSpPr>
+          <p:cNvPr id="2" name="Rectangle 1"/>
+          <p:cNvSpPr/>
+          <p:nvPr/>
+        </p:nvSpPr>
+        <p:spPr>
+          <a:xfrm>
+            <a:off x="0" y="0"/>
+            <a:ext cx="12191695" cy="6858000"/>
+          </a:xfrm>
+          <a:prstGeom prst="rect">
+            <a:avLst/>
+          </a:prstGeom>
+          <a:solidFill>
+            <a:srgbClr val="FFFFFF"/>
+          </a:solidFill>
+          <a:ln>
+            <a:noFill/>
+          </a:ln>
+          <a:effectLst/>
+        </p:spPr>
+        <p:style>
+          <a:lnRef idx="1">
+            <a:schemeClr val="accent1"/>
+          </a:lnRef>
+          <a:fillRef idx="3">
+            <a:schemeClr val="accent1"/>
+          </a:fillRef>
+          <a:effectRef idx="2">
+            <a:schemeClr val="accent1"/>
+          </a:effectRef>
+          <a:fontRef idx="minor">
+            <a:schemeClr val="lt1"/>
+          </a:fontRef>
+        </p:style>
+        <p:txBody>
+          <a:bodyPr rtlCol="0" anchor="ctr"/>
+          <a:lstStyle/>
+          <a:p>
+            <a:pPr algn="ctr"/>
+          </a:p>
+        </p:txBody>
+      </p:sp>
+      <p:sp>
+        <p:nvSpPr>
+          <p:cNvPr id="3" name="TextBox 2"/>
+          <p:cNvSpPr txBox="1"/>
+          <p:nvPr/>
+        </p:nvSpPr>
+        <p:spPr>
+          <a:xfrm>
+            <a:off x="457200" y="320040"/>
+            <a:ext cx="11247120" cy="548640"/>
+          </a:xfrm>
+          <a:prstGeom prst="rect">
+            <a:avLst/>
+          </a:prstGeom>
+          <a:noFill/>
+        </p:spPr>
+        <p:txBody>
+          <a:bodyPr wrap="square" anchor="t" lIns="0" rIns="0" tIns="0" bIns="0">
+            <a:spAutoFit/>
+          </a:bodyPr>
+          <a:lstStyle/>
+          <a:p>
+            <a:pPr algn="l">
+              <a:spcAft>
+                <a:spcPts val="0"/>
+              </a:spcAft>
+            </a:pPr>
+            <a:r>
+              <a:rPr sz="2800" b="1">
+                <a:solidFill>
+                  <a:srgbClr val="1F2A33"/>
+                </a:solidFill>
+                <a:latin typeface="Cambria"/>
+              </a:rPr>
+              <a:t>Status &amp; Next Steps</a:t>
+            </a:r>
+          </a:p>
+        </p:txBody>
+      </p:sp>
+      <p:sp>
+        <p:nvSpPr>
+          <p:cNvPr id="4" name="TextBox 3"/>
+          <p:cNvSpPr txBox="1"/>
+          <p:nvPr/>
+        </p:nvSpPr>
+        <p:spPr>
+          <a:xfrm>
+            <a:off x="457200" y="896112"/>
+            <a:ext cx="11247120" cy="365760"/>
+          </a:xfrm>
+          <a:prstGeom prst="rect">
+            <a:avLst/>
+          </a:prstGeom>
+          <a:noFill/>
+        </p:spPr>
+        <p:txBody>
+          <a:bodyPr wrap="square" anchor="t" lIns="0" rIns="0" tIns="0" bIns="0">
+            <a:spAutoFit/>
+          </a:bodyPr>
+          <a:lstStyle/>
+          <a:p>
+            <a:pPr algn="l">
+              <a:spcAft>
+                <a:spcPts val="0"/>
+              </a:spcAft>
+            </a:pPr>
+            <a:r>
+              <a:rPr sz="1200" b="0">
+                <a:solidFill>
+                  <a:srgbClr val="5B6168"/>
+                </a:solidFill>
+                <a:latin typeface="Calibri"/>
+              </a:rPr>
+              <a:t>The Factory Floor — Industrial Maintenance Copilot (Motors + Variable-Frequency Drives)</a:t>
+            </a:r>
+          </a:p>
+        </p:txBody>
+      </p:sp>
+      <p:sp>
+        <p:nvSpPr>
+          <p:cNvPr id="5" name="Rounded Rectangle 4"/>
+          <p:cNvSpPr/>
+          <p:nvPr/>
+        </p:nvSpPr>
+        <p:spPr>
+          <a:xfrm>
+            <a:off x="457200" y="1463040"/>
+            <a:ext cx="11247120" cy="1051560"/>
+          </a:xfrm>
+          <a:prstGeom prst="roundRect">
+            <a:avLst>
+              <a:gd name="adj" fmla="val 5000"/>
+            </a:avLst>
+          </a:prstGeom>
+          <a:solidFill>
+            <a:srgbClr val="0B6E4F"/>
+          </a:solidFill>
+          <a:ln>
+            <a:noFill/>
+          </a:ln>
+          <a:effectLst/>
+        </p:spPr>
+        <p:style>
+          <a:lnRef idx="1">
+            <a:schemeClr val="accent1"/>
+          </a:lnRef>
+          <a:fillRef idx="3">
+            <a:schemeClr val="accent1"/>
+          </a:fillRef>
+          <a:effectRef idx="2">
+            <a:schemeClr val="accent1"/>
+          </a:effectRef>
+          <a:fontRef idx="minor">
+            <a:schemeClr val="lt1"/>
+          </a:fontRef>
+        </p:style>
+        <p:txBody>
+          <a:bodyPr rtlCol="0" anchor="ctr" wrap="square" lIns="320040" rIns="320040" tIns="109728" bIns="109728"/>
+          <a:lstStyle/>
+          <a:p>
+            <a:pPr algn="l">
+              <a:spcAft>
+                <a:spcPts val="400"/>
+              </a:spcAft>
+            </a:pPr>
+            <a:r>
+              <a:rPr sz="1900" b="1">
+                <a:solidFill>
+                  <a:srgbClr val="FFFFFF"/>
+                </a:solidFill>
+                <a:latin typeface="Calibri"/>
+              </a:rPr>
+              <a:t>✅   ALL MINIMUM REQUIREMENTS COMPLETE</a:t>
+            </a:r>
+          </a:p>
+          <a:p>
+            <a:pPr algn="l">
+              <a:spcAft>
+                <a:spcPts val="0"/>
+              </a:spcAft>
+            </a:pPr>
+            <a:r>
+              <a:rPr sz="1200" b="0">
+                <a:solidFill>
+                  <a:srgbClr val="E4F2EC"/>
+                </a:solidFill>
+                <a:latin typeface="Calibri"/>
+              </a:rPr>
+              <a:t>7 of 7 bootcamp core requirements  ·  9 of 9 roadmap items  ·  RAG · Agent · Tracing · Vision · Evaluation · Safety · Deployment</a:t>
+            </a:r>
+          </a:p>
+        </p:txBody>
+      </p:sp>
+      <p:sp>
+        <p:nvSpPr>
+          <p:cNvPr id="6" name="TextBox 5"/>
+          <p:cNvSpPr txBox="1"/>
+          <p:nvPr/>
+        </p:nvSpPr>
+        <p:spPr>
+          <a:xfrm>
+            <a:off x="457200" y="2743200"/>
+            <a:ext cx="11247120" cy="320040"/>
+          </a:xfrm>
+          <a:prstGeom prst="rect">
+            <a:avLst/>
+          </a:prstGeom>
+          <a:noFill/>
+        </p:spPr>
+        <p:txBody>
+          <a:bodyPr wrap="square" anchor="t" lIns="0" rIns="0" tIns="0" bIns="0">
+            <a:spAutoFit/>
+          </a:bodyPr>
+          <a:lstStyle/>
+          <a:p>
+            <a:pPr algn="l">
+              <a:spcAft>
+                <a:spcPts val="0"/>
+              </a:spcAft>
+            </a:pPr>
+            <a:r>
+              <a:rPr sz="1200" b="1">
+                <a:solidFill>
+                  <a:srgbClr val="0B6E4F"/>
+                </a:solidFill>
+                <a:latin typeface="Calibri"/>
+              </a:rPr>
+              <a:t>WHAT COMES NEXT</a:t>
+            </a:r>
+          </a:p>
+        </p:txBody>
+      </p:sp>
+      <p:sp>
+        <p:nvSpPr>
+          <p:cNvPr id="7" name="Rounded Rectangle 6"/>
+          <p:cNvSpPr/>
+          <p:nvPr/>
+        </p:nvSpPr>
+        <p:spPr>
+          <a:xfrm>
+            <a:off x="457200" y="3127248"/>
+            <a:ext cx="3566160" cy="3063240"/>
+          </a:xfrm>
+          <a:prstGeom prst="roundRect">
+            <a:avLst>
+              <a:gd name="adj" fmla="val 5000"/>
+            </a:avLst>
+          </a:prstGeom>
+          <a:solidFill>
+            <a:srgbClr val="FCEDC7"/>
+          </a:solidFill>
+          <a:ln>
+            <a:noFill/>
+          </a:ln>
+          <a:effectLst/>
+        </p:spPr>
+        <p:style>
+          <a:lnRef idx="1">
+            <a:schemeClr val="accent1"/>
+          </a:lnRef>
+          <a:fillRef idx="3">
+            <a:schemeClr val="accent1"/>
+          </a:fillRef>
+          <a:effectRef idx="2">
+            <a:schemeClr val="accent1"/>
+          </a:effectRef>
+          <a:fontRef idx="minor">
+            <a:schemeClr val="lt1"/>
+          </a:fontRef>
+        </p:style>
+        <p:txBody>
+          <a:bodyPr rtlCol="0" anchor="ctr"/>
+          <a:lstStyle/>
+          <a:p>
+            <a:pPr algn="ctr"/>
+          </a:p>
+        </p:txBody>
+      </p:sp>
+      <p:sp>
+        <p:nvSpPr>
+          <p:cNvPr id="8" name="Rectangle 7"/>
+          <p:cNvSpPr/>
+          <p:nvPr/>
+        </p:nvSpPr>
+        <p:spPr>
+          <a:xfrm>
+            <a:off x="457200" y="3127248"/>
+            <a:ext cx="3566160" cy="82296"/>
+          </a:xfrm>
+          <a:prstGeom prst="rect">
+            <a:avLst/>
+          </a:prstGeom>
+          <a:solidFill>
+            <a:srgbClr val="C98F12"/>
+          </a:solidFill>
+          <a:ln>
+            <a:noFill/>
+          </a:ln>
+          <a:effectLst/>
+        </p:spPr>
+        <p:style>
+          <a:lnRef idx="1">
+            <a:schemeClr val="accent1"/>
+          </a:lnRef>
+          <a:fillRef idx="3">
+            <a:schemeClr val="accent1"/>
+          </a:fillRef>
+          <a:effectRef idx="2">
+            <a:schemeClr val="accent1"/>
+          </a:effectRef>
+          <a:fontRef idx="minor">
+            <a:schemeClr val="lt1"/>
+          </a:fontRef>
+        </p:style>
+        <p:txBody>
+          <a:bodyPr rtlCol="0" anchor="ctr"/>
+          <a:lstStyle/>
+          <a:p>
+            <a:pPr algn="ctr"/>
+          </a:p>
+        </p:txBody>
+      </p:sp>
+      <p:sp>
+        <p:nvSpPr>
+          <p:cNvPr id="9" name="Rounded Rectangle 8"/>
+          <p:cNvSpPr/>
+          <p:nvPr/>
+        </p:nvSpPr>
+        <p:spPr>
+          <a:xfrm>
+            <a:off x="658368" y="3364992"/>
+            <a:ext cx="1234440" cy="256032"/>
+          </a:xfrm>
+          <a:prstGeom prst="roundRect">
+            <a:avLst>
+              <a:gd name="adj" fmla="val 5000"/>
+            </a:avLst>
+          </a:prstGeom>
+          <a:solidFill>
+            <a:srgbClr val="C98F12"/>
+          </a:solidFill>
+          <a:ln>
+            <a:noFill/>
+          </a:ln>
+          <a:effectLst/>
+        </p:spPr>
+        <p:style>
+          <a:lnRef idx="1">
+            <a:schemeClr val="accent1"/>
+          </a:lnRef>
+          <a:fillRef idx="3">
+            <a:schemeClr val="accent1"/>
+          </a:fillRef>
+          <a:effectRef idx="2">
+            <a:schemeClr val="accent1"/>
+          </a:effectRef>
+          <a:fontRef idx="minor">
+            <a:schemeClr val="lt1"/>
+          </a:fontRef>
+        </p:style>
+        <p:txBody>
+          <a:bodyPr rtlCol="0" anchor="ctr" wrap="square" lIns="36576" rIns="36576" tIns="18288" bIns="18288"/>
+          <a:lstStyle/>
+          <a:p>
+            <a:pPr algn="ctr">
+              <a:spcAft>
+                <a:spcPts val="0"/>
+              </a:spcAft>
+            </a:pPr>
+            <a:r>
+              <a:rPr sz="900" b="1">
+                <a:solidFill>
+                  <a:srgbClr val="FFFFFF"/>
+                </a:solidFill>
+                <a:latin typeface="Calibri"/>
+              </a:rPr>
+              <a:t>IN PROGRESS</a:t>
+            </a:r>
+          </a:p>
+        </p:txBody>
+      </p:sp>
+      <p:sp>
+        <p:nvSpPr>
+          <p:cNvPr id="10" name="TextBox 9"/>
+          <p:cNvSpPr txBox="1"/>
+          <p:nvPr/>
+        </p:nvSpPr>
+        <p:spPr>
+          <a:xfrm>
+            <a:off x="658368" y="3730752"/>
+            <a:ext cx="3163824" cy="2286000"/>
+          </a:xfrm>
+          <a:prstGeom prst="rect">
+            <a:avLst/>
+          </a:prstGeom>
+          <a:noFill/>
+        </p:spPr>
+        <p:txBody>
+          <a:bodyPr wrap="square" anchor="t" lIns="0" rIns="0" tIns="0" bIns="0">
+            <a:spAutoFit/>
+          </a:bodyPr>
+          <a:lstStyle/>
+          <a:p>
+            <a:pPr algn="l">
+              <a:spcAft>
+                <a:spcPts val="800"/>
+              </a:spcAft>
+            </a:pPr>
+            <a:r>
+              <a:rPr sz="1500" b="1">
+                <a:solidFill>
+                  <a:srgbClr val="1F2A33"/>
+                </a:solidFill>
+                <a:latin typeface="Calibri"/>
+              </a:rPr>
+              <a:t>Alphanumeric fault codes</a:t>
+            </a:r>
+          </a:p>
+          <a:p>
+            <a:pPr algn="l">
+              <a:spcAft>
+                <a:spcPts val="100"/>
+              </a:spcAft>
+            </a:pPr>
+            <a:r>
+              <a:rPr sz="1050" b="0">
+                <a:solidFill>
+                  <a:srgbClr val="5B6168"/>
+                </a:solidFill>
+                <a:latin typeface="Calibri"/>
+              </a:rPr>
+              <a:t>Embedding search is unreliable for exact codes</a:t>
+            </a:r>
+          </a:p>
+          <a:p>
+            <a:pPr algn="l">
+              <a:spcAft>
+                <a:spcPts val="100"/>
+              </a:spcAft>
+            </a:pPr>
+            <a:r>
+              <a:rPr sz="1050" b="0">
+                <a:solidFill>
+                  <a:srgbClr val="5B6168"/>
+                </a:solidFill>
+                <a:latin typeface="Calibri"/>
+              </a:rPr>
+              <a:t>such as F30021 unless a symptom is typed too.</a:t>
+            </a:r>
+          </a:p>
+          <a:p>
+            <a:pPr algn="l">
+              <a:spcAft>
+                <a:spcPts val="100"/>
+              </a:spcAft>
+            </a:pPr>
+            <a:r>
+              <a:rPr sz="1050" b="0">
+                <a:solidFill>
+                  <a:srgbClr val="5B6168"/>
+                </a:solidFill>
+                <a:latin typeface="Calibri"/>
+              </a:rPr>
+              <a:t> </a:t>
+            </a:r>
+          </a:p>
+          <a:p>
+            <a:pPr algn="l">
+              <a:spcAft>
+                <a:spcPts val="100"/>
+              </a:spcAft>
+            </a:pPr>
+            <a:r>
+              <a:rPr sz="1050" b="0">
+                <a:solidFill>
+                  <a:srgbClr val="5B6168"/>
+                </a:solidFill>
+                <a:latin typeface="Calibri"/>
+              </a:rPr>
+              <a:t>Currently being worked on — the likely direction is</a:t>
+            </a:r>
+          </a:p>
+          <a:p>
+            <a:pPr algn="l">
+              <a:spcAft>
+                <a:spcPts val="100"/>
+              </a:spcAft>
+            </a:pPr>
+            <a:r>
+              <a:rPr sz="1050" b="0">
+                <a:solidFill>
+                  <a:srgbClr val="5B6168"/>
+                </a:solidFill>
+                <a:latin typeface="Calibri"/>
+              </a:rPr>
+              <a:t>hybrid lexical + semantic retrieval, or a guardrail</a:t>
+            </a:r>
+          </a:p>
+          <a:p>
+            <a:pPr algn="l">
+              <a:spcAft>
+                <a:spcPts val="100"/>
+              </a:spcAft>
+            </a:pPr>
+            <a:r>
+              <a:rPr sz="1050" b="0">
+                <a:solidFill>
+                  <a:srgbClr val="5B6168"/>
+                </a:solidFill>
+                <a:latin typeface="Calibri"/>
+              </a:rPr>
+              <a:t>that verifies the code literally appears in the</a:t>
+            </a:r>
+          </a:p>
+          <a:p>
+            <a:pPr algn="l">
+              <a:spcAft>
+                <a:spcPts val="100"/>
+              </a:spcAft>
+            </a:pPr>
+            <a:r>
+              <a:rPr sz="1050" b="0">
+                <a:solidFill>
+                  <a:srgbClr val="5B6168"/>
+                </a:solidFill>
+                <a:latin typeface="Calibri"/>
+              </a:rPr>
+              <a:t>retrieved context before answering.</a:t>
+            </a:r>
+          </a:p>
+        </p:txBody>
+      </p:sp>
+      <p:sp>
+        <p:nvSpPr>
+          <p:cNvPr id="11" name="Rounded Rectangle 10"/>
+          <p:cNvSpPr/>
+          <p:nvPr/>
+        </p:nvSpPr>
+        <p:spPr>
+          <a:xfrm>
+            <a:off x="4251960" y="3127248"/>
+            <a:ext cx="3566160" cy="3063240"/>
+          </a:xfrm>
+          <a:prstGeom prst="roundRect">
+            <a:avLst>
+              <a:gd name="adj" fmla="val 5000"/>
+            </a:avLst>
+          </a:prstGeom>
+          <a:solidFill>
+            <a:srgbClr val="F1F2F3"/>
+          </a:solidFill>
+          <a:ln>
+            <a:noFill/>
+          </a:ln>
+          <a:effectLst/>
+        </p:spPr>
+        <p:style>
+          <a:lnRef idx="1">
+            <a:schemeClr val="accent1"/>
+          </a:lnRef>
+          <a:fillRef idx="3">
+            <a:schemeClr val="accent1"/>
+          </a:fillRef>
+          <a:effectRef idx="2">
+            <a:schemeClr val="accent1"/>
+          </a:effectRef>
+          <a:fontRef idx="minor">
+            <a:schemeClr val="lt1"/>
+          </a:fontRef>
+        </p:style>
+        <p:txBody>
+          <a:bodyPr rtlCol="0" anchor="ctr"/>
+          <a:lstStyle/>
+          <a:p>
+            <a:pPr algn="ctr"/>
+          </a:p>
+        </p:txBody>
+      </p:sp>
+      <p:sp>
+        <p:nvSpPr>
+          <p:cNvPr id="12" name="Rectangle 11"/>
+          <p:cNvSpPr/>
+          <p:nvPr/>
+        </p:nvSpPr>
+        <p:spPr>
+          <a:xfrm>
+            <a:off x="4251960" y="3127248"/>
+            <a:ext cx="3566160" cy="82296"/>
+          </a:xfrm>
+          <a:prstGeom prst="rect">
+            <a:avLst/>
+          </a:prstGeom>
+          <a:solidFill>
+            <a:srgbClr val="BF5B23"/>
+          </a:solidFill>
+          <a:ln>
+            <a:noFill/>
+          </a:ln>
+          <a:effectLst/>
+        </p:spPr>
+        <p:style>
+          <a:lnRef idx="1">
+            <a:schemeClr val="accent1"/>
+          </a:lnRef>
+          <a:fillRef idx="3">
+            <a:schemeClr val="accent1"/>
+          </a:fillRef>
+          <a:effectRef idx="2">
+            <a:schemeClr val="accent1"/>
+          </a:effectRef>
+          <a:fontRef idx="minor">
+            <a:schemeClr val="lt1"/>
+          </a:fontRef>
+        </p:style>
+        <p:txBody>
+          <a:bodyPr rtlCol="0" anchor="ctr"/>
+          <a:lstStyle/>
+          <a:p>
+            <a:pPr algn="ctr"/>
+          </a:p>
+        </p:txBody>
+      </p:sp>
+      <p:sp>
+        <p:nvSpPr>
+          <p:cNvPr id="13" name="Rounded Rectangle 12"/>
+          <p:cNvSpPr/>
+          <p:nvPr/>
+        </p:nvSpPr>
+        <p:spPr>
+          <a:xfrm>
+            <a:off x="4453128" y="3364992"/>
+            <a:ext cx="1234440" cy="256032"/>
+          </a:xfrm>
+          <a:prstGeom prst="roundRect">
+            <a:avLst>
+              <a:gd name="adj" fmla="val 5000"/>
+            </a:avLst>
+          </a:prstGeom>
+          <a:solidFill>
+            <a:srgbClr val="BF5B23"/>
+          </a:solidFill>
+          <a:ln>
+            <a:noFill/>
+          </a:ln>
+          <a:effectLst/>
+        </p:spPr>
+        <p:style>
+          <a:lnRef idx="1">
+            <a:schemeClr val="accent1"/>
+          </a:lnRef>
+          <a:fillRef idx="3">
+            <a:schemeClr val="accent1"/>
+          </a:fillRef>
+          <a:effectRef idx="2">
+            <a:schemeClr val="accent1"/>
+          </a:effectRef>
+          <a:fontRef idx="minor">
+            <a:schemeClr val="lt1"/>
+          </a:fontRef>
+        </p:style>
+        <p:txBody>
+          <a:bodyPr rtlCol="0" anchor="ctr" wrap="square" lIns="36576" rIns="36576" tIns="18288" bIns="18288"/>
+          <a:lstStyle/>
+          <a:p>
+            <a:pPr algn="ctr">
+              <a:spcAft>
+                <a:spcPts val="0"/>
+              </a:spcAft>
+            </a:pPr>
+            <a:r>
+              <a:rPr sz="900" b="1">
+                <a:solidFill>
+                  <a:srgbClr val="FFFFFF"/>
+                </a:solidFill>
+                <a:latin typeface="Calibri"/>
+              </a:rPr>
+              <a:t>NEXT</a:t>
+            </a:r>
+          </a:p>
+        </p:txBody>
+      </p:sp>
+      <p:sp>
+        <p:nvSpPr>
+          <p:cNvPr id="14" name="TextBox 13"/>
+          <p:cNvSpPr txBox="1"/>
+          <p:nvPr/>
+        </p:nvSpPr>
+        <p:spPr>
+          <a:xfrm>
+            <a:off x="4453128" y="3730752"/>
+            <a:ext cx="3163824" cy="2286000"/>
+          </a:xfrm>
+          <a:prstGeom prst="rect">
+            <a:avLst/>
+          </a:prstGeom>
+          <a:noFill/>
+        </p:spPr>
+        <p:txBody>
+          <a:bodyPr wrap="square" anchor="t" lIns="0" rIns="0" tIns="0" bIns="0">
+            <a:spAutoFit/>
+          </a:bodyPr>
+          <a:lstStyle/>
+          <a:p>
+            <a:pPr algn="l">
+              <a:spcAft>
+                <a:spcPts val="800"/>
+              </a:spcAft>
+            </a:pPr>
+            <a:r>
+              <a:rPr sz="1500" b="1">
+                <a:solidFill>
+                  <a:srgbClr val="1F2A33"/>
+                </a:solidFill>
+                <a:latin typeface="Calibri"/>
+              </a:rPr>
+              <a:t>Extensive real-world testing</a:t>
+            </a:r>
+          </a:p>
+          <a:p>
+            <a:pPr algn="l">
+              <a:spcAft>
+                <a:spcPts val="100"/>
+              </a:spcAft>
+            </a:pPr>
+            <a:r>
+              <a:rPr sz="1050" b="0">
+                <a:solidFill>
+                  <a:srgbClr val="5B6168"/>
+                </a:solidFill>
+                <a:latin typeface="Calibri"/>
+              </a:rPr>
+              <a:t>Drive the running app repeatedly, across many</a:t>
+            </a:r>
+          </a:p>
+          <a:p>
+            <a:pPr algn="l">
+              <a:spcAft>
+                <a:spcPts val="100"/>
+              </a:spcAft>
+            </a:pPr>
+            <a:r>
+              <a:rPr sz="1050" b="0">
+                <a:solidFill>
+                  <a:srgbClr val="5B6168"/>
+                </a:solidFill>
+                <a:latin typeface="Calibri"/>
+              </a:rPr>
+              <a:t>machines, codes and phrasings.</a:t>
+            </a:r>
+          </a:p>
+          <a:p>
+            <a:pPr algn="l">
+              <a:spcAft>
+                <a:spcPts val="100"/>
+              </a:spcAft>
+            </a:pPr>
+            <a:r>
+              <a:rPr sz="1050" b="0">
+                <a:solidFill>
+                  <a:srgbClr val="5B6168"/>
+                </a:solidFill>
+                <a:latin typeface="Calibri"/>
+              </a:rPr>
+              <a:t> </a:t>
+            </a:r>
+          </a:p>
+          <a:p>
+            <a:pPr algn="l">
+              <a:spcAft>
+                <a:spcPts val="100"/>
+              </a:spcAft>
+            </a:pPr>
+            <a:r>
+              <a:rPr sz="1050" b="0">
+                <a:solidFill>
+                  <a:srgbClr val="5B6168"/>
+                </a:solidFill>
+                <a:latin typeface="Calibri"/>
+              </a:rPr>
+              <a:t>Notebooks prove each part in isolation; only</a:t>
+            </a:r>
+          </a:p>
+          <a:p>
+            <a:pPr algn="l">
+              <a:spcAft>
+                <a:spcPts val="100"/>
+              </a:spcAft>
+            </a:pPr>
+            <a:r>
+              <a:rPr sz="1050" b="0">
+                <a:solidFill>
+                  <a:srgbClr val="5B6168"/>
+                </a:solidFill>
+                <a:latin typeface="Calibri"/>
+              </a:rPr>
+              <a:t>sustained hands-on use surfaces the failures</a:t>
+            </a:r>
+          </a:p>
+          <a:p>
+            <a:pPr algn="l">
+              <a:spcAft>
+                <a:spcPts val="100"/>
+              </a:spcAft>
+            </a:pPr>
+            <a:r>
+              <a:rPr sz="1050" b="0">
+                <a:solidFill>
+                  <a:srgbClr val="5B6168"/>
+                </a:solidFill>
+                <a:latin typeface="Calibri"/>
+              </a:rPr>
+              <a:t>that matter to an operator.</a:t>
+            </a:r>
+          </a:p>
+        </p:txBody>
+      </p:sp>
+      <p:sp>
+        <p:nvSpPr>
+          <p:cNvPr id="15" name="Rounded Rectangle 14"/>
+          <p:cNvSpPr/>
+          <p:nvPr/>
+        </p:nvSpPr>
+        <p:spPr>
+          <a:xfrm>
+            <a:off x="8046720" y="3127248"/>
+            <a:ext cx="3566160" cy="3063240"/>
+          </a:xfrm>
+          <a:prstGeom prst="roundRect">
+            <a:avLst>
+              <a:gd name="adj" fmla="val 5000"/>
+            </a:avLst>
+          </a:prstGeom>
+          <a:solidFill>
+            <a:srgbClr val="F1F2F3"/>
+          </a:solidFill>
+          <a:ln>
+            <a:noFill/>
+          </a:ln>
+          <a:effectLst/>
+        </p:spPr>
+        <p:style>
+          <a:lnRef idx="1">
+            <a:schemeClr val="accent1"/>
+          </a:lnRef>
+          <a:fillRef idx="3">
+            <a:schemeClr val="accent1"/>
+          </a:fillRef>
+          <a:effectRef idx="2">
+            <a:schemeClr val="accent1"/>
+          </a:effectRef>
+          <a:fontRef idx="minor">
+            <a:schemeClr val="lt1"/>
+          </a:fontRef>
+        </p:style>
+        <p:txBody>
+          <a:bodyPr rtlCol="0" anchor="ctr"/>
+          <a:lstStyle/>
+          <a:p>
+            <a:pPr algn="ctr"/>
+          </a:p>
+        </p:txBody>
+      </p:sp>
+      <p:sp>
+        <p:nvSpPr>
+          <p:cNvPr id="16" name="Rectangle 15"/>
+          <p:cNvSpPr/>
+          <p:nvPr/>
+        </p:nvSpPr>
+        <p:spPr>
+          <a:xfrm>
+            <a:off x="8046720" y="3127248"/>
+            <a:ext cx="3566160" cy="82296"/>
+          </a:xfrm>
+          <a:prstGeom prst="rect">
+            <a:avLst/>
+          </a:prstGeom>
+          <a:solidFill>
+            <a:srgbClr val="8A9096"/>
+          </a:solidFill>
+          <a:ln>
+            <a:noFill/>
+          </a:ln>
+          <a:effectLst/>
+        </p:spPr>
+        <p:style>
+          <a:lnRef idx="1">
+            <a:schemeClr val="accent1"/>
+          </a:lnRef>
+          <a:fillRef idx="3">
+            <a:schemeClr val="accent1"/>
+          </a:fillRef>
+          <a:effectRef idx="2">
+            <a:schemeClr val="accent1"/>
+          </a:effectRef>
+          <a:fontRef idx="minor">
+            <a:schemeClr val="lt1"/>
+          </a:fontRef>
+        </p:style>
+        <p:txBody>
+          <a:bodyPr rtlCol="0" anchor="ctr"/>
+          <a:lstStyle/>
+          <a:p>
+            <a:pPr algn="ctr"/>
+          </a:p>
+        </p:txBody>
+      </p:sp>
+      <p:sp>
+        <p:nvSpPr>
+          <p:cNvPr id="17" name="Rounded Rectangle 16"/>
+          <p:cNvSpPr/>
+          <p:nvPr/>
+        </p:nvSpPr>
+        <p:spPr>
+          <a:xfrm>
+            <a:off x="8247888" y="3364992"/>
+            <a:ext cx="1234440" cy="256032"/>
+          </a:xfrm>
+          <a:prstGeom prst="roundRect">
+            <a:avLst>
+              <a:gd name="adj" fmla="val 5000"/>
+            </a:avLst>
+          </a:prstGeom>
+          <a:solidFill>
+            <a:srgbClr val="8A9096"/>
+          </a:solidFill>
+          <a:ln>
+            <a:noFill/>
+          </a:ln>
+          <a:effectLst/>
+        </p:spPr>
+        <p:style>
+          <a:lnRef idx="1">
+            <a:schemeClr val="accent1"/>
+          </a:lnRef>
+          <a:fillRef idx="3">
+            <a:schemeClr val="accent1"/>
+          </a:fillRef>
+          <a:effectRef idx="2">
+            <a:schemeClr val="accent1"/>
+          </a:effectRef>
+          <a:fontRef idx="minor">
+            <a:schemeClr val="lt1"/>
+          </a:fontRef>
+        </p:style>
+        <p:txBody>
+          <a:bodyPr rtlCol="0" anchor="ctr" wrap="square" lIns="36576" rIns="36576" tIns="18288" bIns="18288"/>
+          <a:lstStyle/>
+          <a:p>
+            <a:pPr algn="ctr">
+              <a:spcAft>
+                <a:spcPts val="0"/>
+              </a:spcAft>
+            </a:pPr>
+            <a:r>
+              <a:rPr sz="900" b="1">
+                <a:solidFill>
+                  <a:srgbClr val="FFFFFF"/>
+                </a:solidFill>
+                <a:latin typeface="Calibri"/>
+              </a:rPr>
+              <a:t>EXPLORING</a:t>
+            </a:r>
+          </a:p>
+        </p:txBody>
+      </p:sp>
+      <p:sp>
+        <p:nvSpPr>
+          <p:cNvPr id="18" name="TextBox 17"/>
+          <p:cNvSpPr txBox="1"/>
+          <p:nvPr/>
+        </p:nvSpPr>
+        <p:spPr>
+          <a:xfrm>
+            <a:off x="8247888" y="3730752"/>
+            <a:ext cx="3163824" cy="2286000"/>
+          </a:xfrm>
+          <a:prstGeom prst="rect">
+            <a:avLst/>
+          </a:prstGeom>
+          <a:noFill/>
+        </p:spPr>
+        <p:txBody>
+          <a:bodyPr wrap="square" anchor="t" lIns="0" rIns="0" tIns="0" bIns="0">
+            <a:spAutoFit/>
+          </a:bodyPr>
+          <a:lstStyle/>
+          <a:p>
+            <a:pPr algn="l">
+              <a:spcAft>
+                <a:spcPts val="800"/>
+              </a:spcAft>
+            </a:pPr>
+            <a:r>
+              <a:rPr sz="1500" b="1">
+                <a:solidFill>
+                  <a:srgbClr val="1F2A33"/>
+                </a:solidFill>
+                <a:latin typeface="Calibri"/>
+              </a:rPr>
+              <a:t>Audio diagnostics</a:t>
+            </a:r>
+          </a:p>
+          <a:p>
+            <a:pPr algn="l">
+              <a:spcAft>
+                <a:spcPts val="100"/>
+              </a:spcAft>
+            </a:pPr>
+            <a:r>
+              <a:rPr sz="1050" b="0">
+                <a:solidFill>
+                  <a:srgbClr val="5B6168"/>
+                </a:solidFill>
+                <a:latin typeface="Calibri"/>
+              </a:rPr>
+              <a:t>The operator uploads the sound the machine was</a:t>
+            </a:r>
+          </a:p>
+          <a:p>
+            <a:pPr algn="l">
+              <a:spcAft>
+                <a:spcPts val="100"/>
+              </a:spcAft>
+            </a:pPr>
+            <a:r>
+              <a:rPr sz="1050" b="0">
+                <a:solidFill>
+                  <a:srgbClr val="5B6168"/>
+                </a:solidFill>
+                <a:latin typeface="Calibri"/>
+              </a:rPr>
+              <a:t>making; the system suggests a likely fault.</a:t>
+            </a:r>
+          </a:p>
+          <a:p>
+            <a:pPr algn="l">
+              <a:spcAft>
+                <a:spcPts val="100"/>
+              </a:spcAft>
+            </a:pPr>
+            <a:r>
+              <a:rPr sz="1050" b="0">
+                <a:solidFill>
+                  <a:srgbClr val="5B6168"/>
+                </a:solidFill>
+                <a:latin typeface="Calibri"/>
+              </a:rPr>
+              <a:t> </a:t>
+            </a:r>
+          </a:p>
+          <a:p>
+            <a:pPr algn="l">
+              <a:spcAft>
+                <a:spcPts val="100"/>
+              </a:spcAft>
+            </a:pPr>
+            <a:r>
+              <a:rPr sz="1050" b="0">
+                <a:solidFill>
+                  <a:srgbClr val="5B6168"/>
+                </a:solidFill>
+                <a:latin typeface="Calibri"/>
+              </a:rPr>
+              <a:t>Not required by the core requirements — the</a:t>
+            </a:r>
+          </a:p>
+          <a:p>
+            <a:pPr algn="l">
+              <a:spcAft>
+                <a:spcPts val="100"/>
+              </a:spcAft>
+            </a:pPr>
+            <a:r>
+              <a:rPr sz="1050" b="0">
+                <a:solidFill>
+                  <a:srgbClr val="5B6168"/>
+                </a:solidFill>
+                <a:latin typeface="Calibri"/>
+              </a:rPr>
+              <a:t>multimodal component is already satisfied by</a:t>
+            </a:r>
+          </a:p>
+          <a:p>
+            <a:pPr algn="l">
+              <a:spcAft>
+                <a:spcPts val="100"/>
+              </a:spcAft>
+            </a:pPr>
+            <a:r>
+              <a:rPr sz="1050" b="0">
+                <a:solidFill>
+                  <a:srgbClr val="5B6168"/>
+                </a:solidFill>
+                <a:latin typeface="Calibri"/>
+              </a:rPr>
+              <a:t>vision. A genuine extra.</a:t>
+            </a:r>
+          </a:p>
+        </p:txBody>
+      </p:sp>
+      <p:sp>
+        <p:nvSpPr>
+          <p:cNvPr id="19" name="TextBox 18"/>
+          <p:cNvSpPr txBox="1"/>
+          <p:nvPr/>
+        </p:nvSpPr>
+        <p:spPr>
+          <a:xfrm>
+            <a:off x="457200" y="6419088"/>
+            <a:ext cx="11247120" cy="320040"/>
+          </a:xfrm>
+          <a:prstGeom prst="rect">
+            <a:avLst/>
+          </a:prstGeom>
+          <a:noFill/>
+        </p:spPr>
+        <p:txBody>
+          <a:bodyPr wrap="square" anchor="t" lIns="0" rIns="0" tIns="0" bIns="0">
+            <a:spAutoFit/>
+          </a:bodyPr>
+          <a:lstStyle/>
+          <a:p>
+            <a:pPr algn="l">
+              <a:spcAft>
+                <a:spcPts val="0"/>
+              </a:spcAft>
+            </a:pPr>
+            <a:r>
+              <a:rPr sz="950" b="0">
+                <a:solidFill>
+                  <a:srgbClr val="8A9096"/>
+                </a:solidFill>
+                <a:latin typeface="Calibri"/>
+              </a:rPr>
+              <a:t>Status as of 25 August 2026</a:t>
+            </a:r>
+          </a:p>
+        </p:txBody>
+      </p:sp>
+    </p:spTree>
+  </p:cSld>
+  <p:clrMapOvr>
+    <a:masterClrMapping/>
+  </p:clrMapOvr>
+</p:sld>
+</file>
+
 <file path=ppt/theme/theme1.xml><?xml version="1.0" encoding="utf-8"?>
 <a:theme xmlns:a="http://schemas.openxmlformats.org/drawingml/2006/main" name="Office Theme">
   <a:themeElements>

</xml_diff>

<commit_message>
Update roadmap slide 5: fault codes done, testing now the active work
The alphanumeric fault-code card moves from IN PROGRESS to DONE and carries the
measured before/after (definition page 18% -> 100%, contains the code 82% ->
100%) plus the refusal behaviour for unknown codes. Real-world testing takes
over the IN PROGRESS slot, since it is what follows now.

Co-Authored-By: Claude Sonnet 5 <noreply@anthropic.com>
Claude-Session: https://claude.ai/code/session_011iVgkFb4vk7QSuG3Z7ovqV
</commit_message>
<xml_diff>
--- a/roadmap.pptx
+++ b/roadmap.pptx
@@ -8347,7 +8347,7 @@
             </a:avLst>
           </a:prstGeom>
           <a:solidFill>
-            <a:srgbClr val="FCEDC7"/>
+            <a:srgbClr val="E4F2EC"/>
           </a:solidFill>
           <a:ln>
             <a:noFill/>
@@ -8391,7 +8391,7 @@
             <a:avLst/>
           </a:prstGeom>
           <a:solidFill>
-            <a:srgbClr val="C98F12"/>
+            <a:srgbClr val="0B6E4F"/>
           </a:solidFill>
           <a:ln>
             <a:noFill/>
@@ -8437,7 +8437,7 @@
             </a:avLst>
           </a:prstGeom>
           <a:solidFill>
-            <a:srgbClr val="C98F12"/>
+            <a:srgbClr val="0B6E4F"/>
           </a:solidFill>
           <a:ln>
             <a:noFill/>
@@ -8474,7 +8474,7 @@
                 </a:solidFill>
                 <a:latin typeface="Calibri"/>
               </a:rPr>
-              <a:t>IN PROGRESS</a:t>
+              <a:t>DONE</a:t>
             </a:r>
           </a:p>
         </p:txBody>
@@ -8529,7 +8529,7 @@
                 </a:solidFill>
                 <a:latin typeface="Calibri"/>
               </a:rPr>
-              <a:t>Embedding search is unreliable for exact codes</a:t>
+              <a:t>Codes are now looked up literally, not searched</a:t>
             </a:r>
           </a:p>
           <a:p>
@@ -8545,7 +8545,71 @@
                 </a:solidFill>
                 <a:latin typeface="Calibri"/>
               </a:rPr>
-              <a:t>such as F30021 unless a symptom is typed too.</a:t>
+              <a:t>semantically — an embedding has no meaning to</a:t>
+            </a:r>
+          </a:p>
+          <a:p>
+            <a:pPr algn="l">
+              <a:spcAft>
+                <a:spcPts val="600"/>
+              </a:spcAft>
+            </a:pPr>
+            <a:r>
+              <a:rPr sz="1050" b="0">
+                <a:solidFill>
+                  <a:srgbClr val="5B6168"/>
+                </a:solidFill>
+                <a:latin typeface="Calibri"/>
+              </a:rPr>
+              <a:t>attach to "F30021".</a:t>
+            </a:r>
+          </a:p>
+          <a:p>
+            <a:pPr algn="l">
+              <a:spcAft>
+                <a:spcPts val="300"/>
+              </a:spcAft>
+            </a:pPr>
+            <a:r>
+              <a:rPr sz="1050" b="1">
+                <a:solidFill>
+                  <a:srgbClr val="1F2A33"/>
+                </a:solidFill>
+                <a:latin typeface="Calibri"/>
+              </a:rPr>
+              <a:t>Querying with the code alone:</a:t>
+            </a:r>
+          </a:p>
+          <a:p>
+            <a:pPr algn="l">
+              <a:spcAft>
+                <a:spcPts val="200"/>
+              </a:spcAft>
+            </a:pPr>
+            <a:r>
+              <a:rPr sz="1150" b="1">
+                <a:solidFill>
+                  <a:srgbClr val="0B6E4F"/>
+                </a:solidFill>
+                <a:latin typeface="Calibri"/>
+              </a:rPr>
+              <a:t>brings the definition page   18% → 100%</a:t>
+            </a:r>
+          </a:p>
+          <a:p>
+            <a:pPr algn="l">
+              <a:spcAft>
+                <a:spcPts val="600"/>
+              </a:spcAft>
+            </a:pPr>
+            <a:r>
+              <a:rPr sz="1150" b="1">
+                <a:solidFill>
+                  <a:srgbClr val="0B6E4F"/>
+                </a:solidFill>
+                <a:latin typeface="Calibri"/>
+              </a:rPr>
+              <a:t>contains the code                82% → 100%</a:t>
             </a:r>
           </a:p>
           <a:p>
@@ -8561,13 +8625,13 @@
                 </a:solidFill>
                 <a:latin typeface="Calibri"/>
               </a:rPr>
-              <a:t> </a:t>
+              <a:t>An unknown code is now refused outright</a:t>
             </a:r>
           </a:p>
           <a:p>
             <a:pPr algn="l">
               <a:spcAft>
-                <a:spcPts val="100"/>
+                <a:spcPts val="0"/>
               </a:spcAft>
             </a:pPr>
             <a:r>
@@ -8577,55 +8641,7 @@
                 </a:solidFill>
                 <a:latin typeface="Calibri"/>
               </a:rPr>
-              <a:t>Currently being worked on — the likely direction is</a:t>
-            </a:r>
-          </a:p>
-          <a:p>
-            <a:pPr algn="l">
-              <a:spcAft>
-                <a:spcPts val="100"/>
-              </a:spcAft>
-            </a:pPr>
-            <a:r>
-              <a:rPr sz="1050" b="0">
-                <a:solidFill>
-                  <a:srgbClr val="5B6168"/>
-                </a:solidFill>
-                <a:latin typeface="Calibri"/>
-              </a:rPr>
-              <a:t>hybrid lexical + semantic retrieval, or a guardrail</a:t>
-            </a:r>
-          </a:p>
-          <a:p>
-            <a:pPr algn="l">
-              <a:spcAft>
-                <a:spcPts val="100"/>
-              </a:spcAft>
-            </a:pPr>
-            <a:r>
-              <a:rPr sz="1050" b="0">
-                <a:solidFill>
-                  <a:srgbClr val="5B6168"/>
-                </a:solidFill>
-                <a:latin typeface="Calibri"/>
-              </a:rPr>
-              <a:t>that verifies the code literally appears in the</a:t>
-            </a:r>
-          </a:p>
-          <a:p>
-            <a:pPr algn="l">
-              <a:spcAft>
-                <a:spcPts val="100"/>
-              </a:spcAft>
-            </a:pPr>
-            <a:r>
-              <a:rPr sz="1050" b="0">
-                <a:solidFill>
-                  <a:srgbClr val="5B6168"/>
-                </a:solidFill>
-                <a:latin typeface="Calibri"/>
-              </a:rPr>
-              <a:t>retrieved context before answering.</a:t>
+              <a:t>instead of answered from a similar one.</a:t>
             </a:r>
           </a:p>
         </p:txBody>
@@ -8647,7 +8663,7 @@
             </a:avLst>
           </a:prstGeom>
           <a:solidFill>
-            <a:srgbClr val="F1F2F3"/>
+            <a:srgbClr val="FCEDC7"/>
           </a:solidFill>
           <a:ln>
             <a:noFill/>
@@ -8691,7 +8707,7 @@
             <a:avLst/>
           </a:prstGeom>
           <a:solidFill>
-            <a:srgbClr val="BF5B23"/>
+            <a:srgbClr val="C98F12"/>
           </a:solidFill>
           <a:ln>
             <a:noFill/>
@@ -8737,7 +8753,7 @@
             </a:avLst>
           </a:prstGeom>
           <a:solidFill>
-            <a:srgbClr val="BF5B23"/>
+            <a:srgbClr val="C98F12"/>
           </a:solidFill>
           <a:ln>
             <a:noFill/>
@@ -8774,7 +8790,7 @@
                 </a:solidFill>
                 <a:latin typeface="Calibri"/>
               </a:rPr>
-              <a:t>NEXT</a:t>
+              <a:t>IN PROGRESS</a:t>
             </a:r>
           </a:p>
         </p:txBody>

</xml_diff>